<commit_message>
Frame project question around dealership contact priorities
</commit_message>
<xml_diff>
--- a/docs/P2/EV_Customer_Prioritization_Stakeholder_Presentation.pptx
+++ b/docs/P2/EV_Customer_Prioritization_Stakeholder_Presentation.pptx
@@ -745,6 +745,16 @@
         <p:txBody>
           <a:bodyPr xmlns:a="http://schemas.openxmlformats.org/drawingml/2006/main"/>
           <a:lstStyle xmlns:a="http://schemas.openxmlformats.org/drawingml/2006/main"/>
+          <a:p xmlns:a="http://schemas.openxmlformats.org/drawingml/2006/main">
+            <a:r>
+              <a:t>Business question: Which customers should an EV dealership prioritize for contact when its outreach capacity is limited?</a:t>
+            </a:r>
+          </a:p>
+          <a:p xmlns:a="http://schemas.openxmlformats.org/drawingml/2006/main">
+            <a:r>
+              <a:t/>
+            </a:r>
+          </a:p>
           <a:p xmlns:a="http://schemas.openxmlformats.org/drawingml/2006/main">
             <a:r>
               <a:t>The number 50 is an illustration of a manager’s capacity, not an observed outreach result. A manager can change this limit in the tool. The product returns ranked profile IDs and recorded fields so staff can review the shortlist before deciding whether contact is appropriate.</a:t>
@@ -4929,6 +4939,7 @@
               </a:defRPr>
             </a:defPPr>
             <a:lvl1pPr>
+              <a:buNone/>
               <a:defRPr sz="3300" b="1">
                 <a:solidFill>
                   <a:srgbClr val="102C32"/>
@@ -4939,6 +4950,7 @@
               </a:defRPr>
             </a:lvl1pPr>
             <a:lvl2pPr>
+              <a:buNone/>
               <a:defRPr sz="3300" b="1">
                 <a:solidFill>
                   <a:srgbClr val="102C32"/>
@@ -4949,6 +4961,7 @@
               </a:defRPr>
             </a:lvl2pPr>
             <a:lvl3pPr>
+              <a:buNone/>
               <a:defRPr sz="3300" b="1">
                 <a:solidFill>
                   <a:srgbClr val="102C32"/>
@@ -4959,6 +4972,7 @@
               </a:defRPr>
             </a:lvl3pPr>
             <a:lvl4pPr>
+              <a:buNone/>
               <a:defRPr sz="3300" b="1">
                 <a:solidFill>
                   <a:srgbClr val="102C32"/>
@@ -4969,6 +4983,7 @@
               </a:defRPr>
             </a:lvl4pPr>
             <a:lvl5pPr>
+              <a:buNone/>
               <a:defRPr sz="3300" b="1">
                 <a:solidFill>
                   <a:srgbClr val="102C32"/>
@@ -4979,6 +4994,7 @@
               </a:defRPr>
             </a:lvl5pPr>
             <a:lvl6pPr>
+              <a:buNone/>
               <a:defRPr sz="3300" b="1">
                 <a:solidFill>
                   <a:srgbClr val="102C32"/>
@@ -4989,6 +5005,7 @@
               </a:defRPr>
             </a:lvl6pPr>
             <a:lvl7pPr>
+              <a:buNone/>
               <a:defRPr sz="3300" b="1">
                 <a:solidFill>
                   <a:srgbClr val="102C32"/>
@@ -4999,6 +5016,7 @@
               </a:defRPr>
             </a:lvl7pPr>
             <a:lvl8pPr>
+              <a:buNone/>
               <a:defRPr sz="3300" b="1">
                 <a:solidFill>
                   <a:srgbClr val="102C32"/>
@@ -5009,6 +5027,7 @@
               </a:defRPr>
             </a:lvl8pPr>
             <a:lvl9pPr>
+              <a:buNone/>
               <a:defRPr sz="3300" b="1">
                 <a:solidFill>
                   <a:srgbClr val="102C32"/>
@@ -5204,6 +5223,7 @@
               </a:defRPr>
             </a:defPPr>
             <a:lvl1pPr algn="l">
+              <a:buNone/>
               <a:defRPr sz="3225" b="1">
                 <a:solidFill>
                   <a:srgbClr val="102C32"/>
@@ -5214,6 +5234,7 @@
               </a:defRPr>
             </a:lvl1pPr>
             <a:lvl2pPr algn="l">
+              <a:buNone/>
               <a:defRPr sz="3225" b="1">
                 <a:solidFill>
                   <a:srgbClr val="102C32"/>
@@ -5224,6 +5245,7 @@
               </a:defRPr>
             </a:lvl2pPr>
             <a:lvl3pPr algn="l">
+              <a:buNone/>
               <a:defRPr sz="3225" b="1">
                 <a:solidFill>
                   <a:srgbClr val="102C32"/>
@@ -5234,6 +5256,7 @@
               </a:defRPr>
             </a:lvl3pPr>
             <a:lvl4pPr algn="l">
+              <a:buNone/>
               <a:defRPr sz="3225" b="1">
                 <a:solidFill>
                   <a:srgbClr val="102C32"/>
@@ -5244,6 +5267,7 @@
               </a:defRPr>
             </a:lvl4pPr>
             <a:lvl5pPr algn="l">
+              <a:buNone/>
               <a:defRPr sz="3225" b="1">
                 <a:solidFill>
                   <a:srgbClr val="102C32"/>
@@ -5254,6 +5278,7 @@
               </a:defRPr>
             </a:lvl5pPr>
             <a:lvl6pPr algn="l">
+              <a:buNone/>
               <a:defRPr sz="3225" b="1">
                 <a:solidFill>
                   <a:srgbClr val="102C32"/>
@@ -5264,6 +5289,7 @@
               </a:defRPr>
             </a:lvl6pPr>
             <a:lvl7pPr algn="l">
+              <a:buNone/>
               <a:defRPr sz="3225" b="1">
                 <a:solidFill>
                   <a:srgbClr val="102C32"/>
@@ -5274,6 +5300,7 @@
               </a:defRPr>
             </a:lvl7pPr>
             <a:lvl8pPr algn="l">
+              <a:buNone/>
               <a:defRPr sz="3225" b="1">
                 <a:solidFill>
                   <a:srgbClr val="102C32"/>
@@ -5284,6 +5311,7 @@
               </a:defRPr>
             </a:lvl8pPr>
             <a:lvl9pPr algn="l">
+              <a:buNone/>
               <a:defRPr sz="3225" b="1">
                 <a:solidFill>
                   <a:srgbClr val="102C32"/>
@@ -5296,6 +5324,7 @@
           </a:lstStyle>
           <a:p xmlns:a="http://schemas.openxmlformats.org/drawingml/2006/main">
             <a:pPr algn="l">
+              <a:buNone/>
               <a:defRPr sz="3225" b="1">
                 <a:solidFill>
                   <a:srgbClr val="102C32"/>
@@ -5314,7 +5343,7 @@
                 <a:ea typeface="Arial"/>
                 <a:cs typeface="Arial"/>
               </a:rPr>
-              <a:t>Which profiles should receive review first?</a:t>
+              <a:t>Which customers should an EV dealership prioritize for contact when its outreach capacity is limited?</a:t>
             </a:r>
           </a:p>
         </p:txBody>
@@ -5362,6 +5391,7 @@
               </a:defRPr>
             </a:defPPr>
             <a:lvl1pPr algn="l">
+              <a:buNone/>
               <a:defRPr sz="2025" b="1">
                 <a:solidFill>
                   <a:srgbClr val="15866C"/>
@@ -5372,6 +5402,7 @@
               </a:defRPr>
             </a:lvl1pPr>
             <a:lvl2pPr algn="l">
+              <a:buNone/>
               <a:defRPr sz="2025" b="1">
                 <a:solidFill>
                   <a:srgbClr val="15866C"/>
@@ -5382,6 +5413,7 @@
               </a:defRPr>
             </a:lvl2pPr>
             <a:lvl3pPr algn="l">
+              <a:buNone/>
               <a:defRPr sz="2025" b="1">
                 <a:solidFill>
                   <a:srgbClr val="15866C"/>
@@ -5392,6 +5424,7 @@
               </a:defRPr>
             </a:lvl3pPr>
             <a:lvl4pPr algn="l">
+              <a:buNone/>
               <a:defRPr sz="2025" b="1">
                 <a:solidFill>
                   <a:srgbClr val="15866C"/>
@@ -5402,6 +5435,7 @@
               </a:defRPr>
             </a:lvl4pPr>
             <a:lvl5pPr algn="l">
+              <a:buNone/>
               <a:defRPr sz="2025" b="1">
                 <a:solidFill>
                   <a:srgbClr val="15866C"/>
@@ -5412,6 +5446,7 @@
               </a:defRPr>
             </a:lvl5pPr>
             <a:lvl6pPr algn="l">
+              <a:buNone/>
               <a:defRPr sz="2025" b="1">
                 <a:solidFill>
                   <a:srgbClr val="15866C"/>
@@ -5422,6 +5457,7 @@
               </a:defRPr>
             </a:lvl6pPr>
             <a:lvl7pPr algn="l">
+              <a:buNone/>
               <a:defRPr sz="2025" b="1">
                 <a:solidFill>
                   <a:srgbClr val="15866C"/>
@@ -5432,6 +5468,7 @@
               </a:defRPr>
             </a:lvl7pPr>
             <a:lvl8pPr algn="l">
+              <a:buNone/>
               <a:defRPr sz="2025" b="1">
                 <a:solidFill>
                   <a:srgbClr val="15866C"/>
@@ -5442,6 +5479,7 @@
               </a:defRPr>
             </a:lvl8pPr>
             <a:lvl9pPr algn="l">
+              <a:buNone/>
               <a:defRPr sz="2025" b="1">
                 <a:solidFill>
                   <a:srgbClr val="15866C"/>
@@ -5454,6 +5492,7 @@
           </a:lstStyle>
           <a:p xmlns:a="http://schemas.openxmlformats.org/drawingml/2006/main">
             <a:pPr algn="l">
+              <a:buNone/>
               <a:defRPr sz="2025" b="1">
                 <a:solidFill>
                   <a:srgbClr val="15866C"/>
@@ -5520,6 +5559,7 @@
               </a:defRPr>
             </a:defPPr>
             <a:lvl1pPr algn="l">
+              <a:buNone/>
               <a:defRPr sz="2175" b="0">
                 <a:solidFill>
                   <a:srgbClr val="102C32"/>
@@ -5530,6 +5570,7 @@
               </a:defRPr>
             </a:lvl1pPr>
             <a:lvl2pPr algn="l">
+              <a:buNone/>
               <a:defRPr sz="2175" b="0">
                 <a:solidFill>
                   <a:srgbClr val="102C32"/>
@@ -5540,6 +5581,7 @@
               </a:defRPr>
             </a:lvl2pPr>
             <a:lvl3pPr algn="l">
+              <a:buNone/>
               <a:defRPr sz="2175" b="0">
                 <a:solidFill>
                   <a:srgbClr val="102C32"/>
@@ -5550,6 +5592,7 @@
               </a:defRPr>
             </a:lvl3pPr>
             <a:lvl4pPr algn="l">
+              <a:buNone/>
               <a:defRPr sz="2175" b="0">
                 <a:solidFill>
                   <a:srgbClr val="102C32"/>
@@ -5560,6 +5603,7 @@
               </a:defRPr>
             </a:lvl4pPr>
             <a:lvl5pPr algn="l">
+              <a:buNone/>
               <a:defRPr sz="2175" b="0">
                 <a:solidFill>
                   <a:srgbClr val="102C32"/>
@@ -5570,6 +5614,7 @@
               </a:defRPr>
             </a:lvl5pPr>
             <a:lvl6pPr algn="l">
+              <a:buNone/>
               <a:defRPr sz="2175" b="0">
                 <a:solidFill>
                   <a:srgbClr val="102C32"/>
@@ -5580,6 +5625,7 @@
               </a:defRPr>
             </a:lvl6pPr>
             <a:lvl7pPr algn="l">
+              <a:buNone/>
               <a:defRPr sz="2175" b="0">
                 <a:solidFill>
                   <a:srgbClr val="102C32"/>
@@ -5590,6 +5636,7 @@
               </a:defRPr>
             </a:lvl7pPr>
             <a:lvl8pPr algn="l">
+              <a:buNone/>
               <a:defRPr sz="2175" b="0">
                 <a:solidFill>
                   <a:srgbClr val="102C32"/>
@@ -5600,6 +5647,7 @@
               </a:defRPr>
             </a:lvl8pPr>
             <a:lvl9pPr algn="l">
+              <a:buNone/>
               <a:defRPr sz="2175" b="0">
                 <a:solidFill>
                   <a:srgbClr val="102C32"/>
@@ -5612,6 +5660,7 @@
           </a:lstStyle>
           <a:p xmlns:a="http://schemas.openxmlformats.org/drawingml/2006/main">
             <a:pPr algn="l">
+              <a:buNone/>
               <a:defRPr sz="2175" b="0">
                 <a:solidFill>
                   <a:srgbClr val="102C32"/>
@@ -5635,6 +5684,7 @@
           </a:p>
           <a:p xmlns:a="http://schemas.openxmlformats.org/drawingml/2006/main">
             <a:pPr algn="l">
+              <a:buNone/>
               <a:defRPr sz="2175" b="0">
                 <a:solidFill>
                   <a:srgbClr val="102C32"/>
@@ -5658,6 +5708,7 @@
           </a:p>
           <a:p xmlns:a="http://schemas.openxmlformats.org/drawingml/2006/main">
             <a:pPr algn="l">
+              <a:buNone/>
               <a:defRPr sz="2175" b="0">
                 <a:solidFill>
                   <a:srgbClr val="102C32"/>
@@ -5724,6 +5775,7 @@
               </a:defRPr>
             </a:defPPr>
             <a:lvl1pPr algn="l">
+              <a:buNone/>
               <a:defRPr sz="2025" b="1">
                 <a:solidFill>
                   <a:srgbClr val="15866C"/>
@@ -5734,6 +5786,7 @@
               </a:defRPr>
             </a:lvl1pPr>
             <a:lvl2pPr algn="l">
+              <a:buNone/>
               <a:defRPr sz="2025" b="1">
                 <a:solidFill>
                   <a:srgbClr val="15866C"/>
@@ -5744,6 +5797,7 @@
               </a:defRPr>
             </a:lvl2pPr>
             <a:lvl3pPr algn="l">
+              <a:buNone/>
               <a:defRPr sz="2025" b="1">
                 <a:solidFill>
                   <a:srgbClr val="15866C"/>
@@ -5754,6 +5808,7 @@
               </a:defRPr>
             </a:lvl3pPr>
             <a:lvl4pPr algn="l">
+              <a:buNone/>
               <a:defRPr sz="2025" b="1">
                 <a:solidFill>
                   <a:srgbClr val="15866C"/>
@@ -5764,6 +5819,7 @@
               </a:defRPr>
             </a:lvl4pPr>
             <a:lvl5pPr algn="l">
+              <a:buNone/>
               <a:defRPr sz="2025" b="1">
                 <a:solidFill>
                   <a:srgbClr val="15866C"/>
@@ -5774,6 +5830,7 @@
               </a:defRPr>
             </a:lvl5pPr>
             <a:lvl6pPr algn="l">
+              <a:buNone/>
               <a:defRPr sz="2025" b="1">
                 <a:solidFill>
                   <a:srgbClr val="15866C"/>
@@ -5784,6 +5841,7 @@
               </a:defRPr>
             </a:lvl6pPr>
             <a:lvl7pPr algn="l">
+              <a:buNone/>
               <a:defRPr sz="2025" b="1">
                 <a:solidFill>
                   <a:srgbClr val="15866C"/>
@@ -5794,6 +5852,7 @@
               </a:defRPr>
             </a:lvl7pPr>
             <a:lvl8pPr algn="l">
+              <a:buNone/>
               <a:defRPr sz="2025" b="1">
                 <a:solidFill>
                   <a:srgbClr val="15866C"/>
@@ -5804,6 +5863,7 @@
               </a:defRPr>
             </a:lvl8pPr>
             <a:lvl9pPr algn="l">
+              <a:buNone/>
               <a:defRPr sz="2025" b="1">
                 <a:solidFill>
                   <a:srgbClr val="15866C"/>
@@ -5816,6 +5876,7 @@
           </a:lstStyle>
           <a:p xmlns:a="http://schemas.openxmlformats.org/drawingml/2006/main">
             <a:pPr algn="l">
+              <a:buNone/>
               <a:defRPr sz="2025" b="1">
                 <a:solidFill>
                   <a:srgbClr val="15866C"/>
@@ -5882,6 +5943,7 @@
               </a:defRPr>
             </a:defPPr>
             <a:lvl1pPr algn="l">
+              <a:buNone/>
               <a:defRPr sz="2175" b="0">
                 <a:solidFill>
                   <a:srgbClr val="102C32"/>
@@ -5892,6 +5954,7 @@
               </a:defRPr>
             </a:lvl1pPr>
             <a:lvl2pPr algn="l">
+              <a:buNone/>
               <a:defRPr sz="2175" b="0">
                 <a:solidFill>
                   <a:srgbClr val="102C32"/>
@@ -5902,6 +5965,7 @@
               </a:defRPr>
             </a:lvl2pPr>
             <a:lvl3pPr algn="l">
+              <a:buNone/>
               <a:defRPr sz="2175" b="0">
                 <a:solidFill>
                   <a:srgbClr val="102C32"/>
@@ -5912,6 +5976,7 @@
               </a:defRPr>
             </a:lvl3pPr>
             <a:lvl4pPr algn="l">
+              <a:buNone/>
               <a:defRPr sz="2175" b="0">
                 <a:solidFill>
                   <a:srgbClr val="102C32"/>
@@ -5922,6 +5987,7 @@
               </a:defRPr>
             </a:lvl4pPr>
             <a:lvl5pPr algn="l">
+              <a:buNone/>
               <a:defRPr sz="2175" b="0">
                 <a:solidFill>
                   <a:srgbClr val="102C32"/>
@@ -5932,6 +5998,7 @@
               </a:defRPr>
             </a:lvl5pPr>
             <a:lvl6pPr algn="l">
+              <a:buNone/>
               <a:defRPr sz="2175" b="0">
                 <a:solidFill>
                   <a:srgbClr val="102C32"/>
@@ -5942,6 +6009,7 @@
               </a:defRPr>
             </a:lvl6pPr>
             <a:lvl7pPr algn="l">
+              <a:buNone/>
               <a:defRPr sz="2175" b="0">
                 <a:solidFill>
                   <a:srgbClr val="102C32"/>
@@ -5952,6 +6020,7 @@
               </a:defRPr>
             </a:lvl7pPr>
             <a:lvl8pPr algn="l">
+              <a:buNone/>
               <a:defRPr sz="2175" b="0">
                 <a:solidFill>
                   <a:srgbClr val="102C32"/>
@@ -5962,6 +6031,7 @@
               </a:defRPr>
             </a:lvl8pPr>
             <a:lvl9pPr algn="l">
+              <a:buNone/>
               <a:defRPr sz="2175" b="0">
                 <a:solidFill>
                   <a:srgbClr val="102C32"/>
@@ -5974,6 +6044,7 @@
           </a:lstStyle>
           <a:p xmlns:a="http://schemas.openxmlformats.org/drawingml/2006/main">
             <a:pPr algn="l">
+              <a:buNone/>
               <a:defRPr sz="2175" b="0">
                 <a:solidFill>
                   <a:srgbClr val="102C32"/>
@@ -5997,6 +6068,7 @@
           </a:p>
           <a:p xmlns:a="http://schemas.openxmlformats.org/drawingml/2006/main">
             <a:pPr algn="l">
+              <a:buNone/>
               <a:defRPr sz="2175" b="0">
                 <a:solidFill>
                   <a:srgbClr val="102C32"/>
@@ -6020,6 +6092,7 @@
           </a:p>
           <a:p xmlns:a="http://schemas.openxmlformats.org/drawingml/2006/main">
             <a:pPr algn="l">
+              <a:buNone/>
               <a:defRPr sz="2175" b="0">
                 <a:solidFill>
                   <a:srgbClr val="102C32"/>
@@ -6086,6 +6159,7 @@
               </a:defRPr>
             </a:defPPr>
             <a:lvl1pPr algn="l">
+              <a:buNone/>
               <a:defRPr sz="2175" b="1">
                 <a:solidFill>
                   <a:srgbClr val="102C32"/>
@@ -6096,6 +6170,7 @@
               </a:defRPr>
             </a:lvl1pPr>
             <a:lvl2pPr algn="l">
+              <a:buNone/>
               <a:defRPr sz="2175" b="1">
                 <a:solidFill>
                   <a:srgbClr val="102C32"/>
@@ -6106,6 +6181,7 @@
               </a:defRPr>
             </a:lvl2pPr>
             <a:lvl3pPr algn="l">
+              <a:buNone/>
               <a:defRPr sz="2175" b="1">
                 <a:solidFill>
                   <a:srgbClr val="102C32"/>
@@ -6116,6 +6192,7 @@
               </a:defRPr>
             </a:lvl3pPr>
             <a:lvl4pPr algn="l">
+              <a:buNone/>
               <a:defRPr sz="2175" b="1">
                 <a:solidFill>
                   <a:srgbClr val="102C32"/>
@@ -6126,6 +6203,7 @@
               </a:defRPr>
             </a:lvl4pPr>
             <a:lvl5pPr algn="l">
+              <a:buNone/>
               <a:defRPr sz="2175" b="1">
                 <a:solidFill>
                   <a:srgbClr val="102C32"/>
@@ -6136,6 +6214,7 @@
               </a:defRPr>
             </a:lvl5pPr>
             <a:lvl6pPr algn="l">
+              <a:buNone/>
               <a:defRPr sz="2175" b="1">
                 <a:solidFill>
                   <a:srgbClr val="102C32"/>
@@ -6146,6 +6225,7 @@
               </a:defRPr>
             </a:lvl6pPr>
             <a:lvl7pPr algn="l">
+              <a:buNone/>
               <a:defRPr sz="2175" b="1">
                 <a:solidFill>
                   <a:srgbClr val="102C32"/>
@@ -6156,6 +6236,7 @@
               </a:defRPr>
             </a:lvl7pPr>
             <a:lvl8pPr algn="l">
+              <a:buNone/>
               <a:defRPr sz="2175" b="1">
                 <a:solidFill>
                   <a:srgbClr val="102C32"/>
@@ -6166,6 +6247,7 @@
               </a:defRPr>
             </a:lvl8pPr>
             <a:lvl9pPr algn="l">
+              <a:buNone/>
               <a:defRPr sz="2175" b="1">
                 <a:solidFill>
                   <a:srgbClr val="102C32"/>
@@ -6178,6 +6260,7 @@
           </a:lstStyle>
           <a:p xmlns:a="http://schemas.openxmlformats.org/drawingml/2006/main">
             <a:pPr algn="l">
+              <a:buNone/>
               <a:defRPr sz="2175" b="1">
                 <a:solidFill>
                   <a:srgbClr val="102C32"/>

</xml_diff>